<commit_message>
Add browser-native conference deck
</commit_message>
<xml_diff>
--- a/docs/presentations/literate-ai-evolution-conference/literate-ai-evolution-conference.pptx
+++ b/docs/presentations/literate-ai-evolution-conference/literate-ai-evolution-conference.pptx
@@ -900,7 +900,7 @@
           </a:p>
           <a:p>
             <a:r>
-              <a:t>Invite attendees to open labs/ and the generated HTML authority graph.</a:t>
+              <a:t>Invite attendees to meet the grumpy counter and inspect the generated HTML authority graph.</a:t>
             </a:r>
           </a:p>
         </p:txBody>
@@ -7185,7 +7185,7 @@
                 </a:solidFill>
                 <a:latin typeface="Helvetica Neue"/>
               </a:rPr>
-              <a:t>Six labs teach composition by becoming progressively less sensible.</a:t>
+              <a:t>Six labs make increasingly questionable life choices.</a:t>
             </a:r>
           </a:p>
         </p:txBody>
@@ -7220,7 +7220,7 @@
                 </a:solidFill>
                 <a:latin typeface="Helvetica Neue"/>
               </a:rPr>
-              <a:t>Every lab is one offline HTML artifact with its specification and interactive DAG in view.</a:t>
+              <a:t>No KPI dashboards were harmed. Every lab is offline, free-standing, and inspectable.</a:t>
             </a:r>
           </a:p>
         </p:txBody>
@@ -7987,7 +7987,7 @@
                 </a:solidFill>
                 <a:latin typeface="Helvetica Neue"/>
               </a:rPr>
-              <a:t>The cathedral is the argument: rigor does not have to look corporate.</a:t>
+              <a:t>The cathedral is the argument: rigor can wear better clothes.</a:t>
             </a:r>
           </a:p>
         </p:txBody>
@@ -8022,7 +8022,7 @@
                 </a:solidFill>
                 <a:latin typeface="Helvetica Neue"/>
               </a:rPr>
-              <a:t>Math, physics, 3D, music, audio, and video become replaceable capabilities in one readable DAG.</a:t>
+              <a:t>Yes, it has a pipe organ. No, finance did not ask for it.</a:t>
             </a:r>
           </a:p>
         </p:txBody>
@@ -9763,7 +9763,7 @@
                 </a:solidFill>
                 <a:latin typeface="Helvetica Neue"/>
               </a:rPr>
-              <a:t>rigorous, renewable—and strange.</a:t>
+              <a:t>rigorous, renewable—and fun.</a:t>
             </a:r>
           </a:p>
         </p:txBody>
@@ -9896,7 +9896,7 @@
                 </a:solidFill>
                 <a:latin typeface="Helvetica Neue"/>
               </a:rPr>
-              <a:t>Start with the visual labs. Then inspect the authority graph.</a:t>
+              <a:t>Start with the visual labs. The grumpy counter has opinions.</a:t>
             </a:r>
           </a:p>
         </p:txBody>

</xml_diff>